<commit_message>
Add PostgreSQL support and Railway deployment
Enable optional PostgreSQL backing and add deployment assets. server.js now uses pg Pool when DATABASE_URL is configured (falls back to in-memory data), adds DEFAULT_HOUSEHOLD_ID handling, input validation, and implements DB queries for members, sacraments, transactions, and summary endpoints. Added Dockerfile, .dockerignore, .env.example, and a Railway deployment guide; updated README and package.json (added pg). Inserted seed data into sql/schema.sql and included minor presentation/report/outline updates.
</commit_message>
<xml_diff>
--- a/Coursework/CoU-MIS_Presentation.pptx
+++ b/Coursework/CoU-MIS_Presentation.pptx
@@ -5,21 +5,21 @@
     <p:sldMasterId id="2147483648" r:id="rId1"/>
   </p:sldMasterIdLst>
   <p:sldIdLst>
-    <p:sldId id="256" r:id="rId7"/>
-    <p:sldId id="257" r:id="rId8"/>
-    <p:sldId id="258" r:id="rId9"/>
-    <p:sldId id="259" r:id="rId10"/>
-    <p:sldId id="260" r:id="rId11"/>
-    <p:sldId id="261" r:id="rId12"/>
-    <p:sldId id="262" r:id="rId13"/>
-    <p:sldId id="263" r:id="rId14"/>
-    <p:sldId id="264" r:id="rId15"/>
-    <p:sldId id="265" r:id="rId16"/>
-    <p:sldId id="266" r:id="rId17"/>
-    <p:sldId id="267" r:id="rId18"/>
-    <p:sldId id="268" r:id="rId19"/>
-    <p:sldId id="269" r:id="rId20"/>
-    <p:sldId id="270" r:id="rId21"/>
+    <p:sldId id="256" r:id="rId2"/>
+    <p:sldId id="257" r:id="rId3"/>
+    <p:sldId id="258" r:id="rId4"/>
+    <p:sldId id="259" r:id="rId5"/>
+    <p:sldId id="260" r:id="rId6"/>
+    <p:sldId id="261" r:id="rId7"/>
+    <p:sldId id="262" r:id="rId8"/>
+    <p:sldId id="263" r:id="rId9"/>
+    <p:sldId id="264" r:id="rId10"/>
+    <p:sldId id="265" r:id="rId11"/>
+    <p:sldId id="266" r:id="rId12"/>
+    <p:sldId id="267" r:id="rId13"/>
+    <p:sldId id="268" r:id="rId14"/>
+    <p:sldId id="269" r:id="rId15"/>
+    <p:sldId id="270" r:id="rId16"/>
   </p:sldIdLst>
   <p:sldSz cx="9144000" cy="6858000" type="screen4x3"/>
   <p:notesSz cx="6858000" cy="9144000"/>
@@ -118,6 +118,22 @@
       </a:defRPr>
     </a:lvl9pPr>
   </p:defaultTextStyle>
+  <p:extLst>
+    <p:ext uri="{EFAFB233-063F-42B5-8137-9DF3F51BA10A}">
+      <p15:sldGuideLst xmlns:p15="http://schemas.microsoft.com/office/powerpoint/2012/main">
+        <p15:guide id="1" orient="horz" pos="2160">
+          <p15:clr>
+            <a:srgbClr val="A4A3A4"/>
+          </p15:clr>
+        </p15:guide>
+        <p15:guide id="2" pos="2880">
+          <p15:clr>
+            <a:srgbClr val="A4A3A4"/>
+          </p15:clr>
+        </p15:guide>
+      </p15:sldGuideLst>
+    </p:ext>
+  </p:extLst>
 </p:presentation>
 </file>
 
@@ -159,10 +175,9 @@
           <a:lstStyle/>
           <a:p>
             <a:r>
-              <a:rPr lang="en-US" smtClean="0"/>
+              <a:rPr lang="en-US"/>
               <a:t>Click to edit Master title style</a:t>
             </a:r>
-            <a:endParaRPr lang="en-US"/>
           </a:p>
         </p:txBody>
       </p:sp>
@@ -278,10 +293,9 @@
           </a:lstStyle>
           <a:p>
             <a:r>
-              <a:rPr lang="en-US" smtClean="0"/>
+              <a:rPr lang="en-US"/>
               <a:t>Click to edit Master subtitle style</a:t>
             </a:r>
-            <a:endParaRPr lang="en-US"/>
           </a:p>
         </p:txBody>
       </p:sp>
@@ -302,7 +316,7 @@
           <a:p>
             <a:fld id="{5BCAD085-E8A6-8845-BD4E-CB4CCA059FC4}" type="datetimeFigureOut">
               <a:rPr lang="en-US" smtClean="0"/>
-              <a:t>1/27/13</a:t>
+              <a:t>4/10/2026</a:t>
             </a:fld>
             <a:endParaRPr lang="en-US"/>
           </a:p>
@@ -396,10 +410,9 @@
           <a:lstStyle/>
           <a:p>
             <a:r>
-              <a:rPr lang="en-US" smtClean="0"/>
+              <a:rPr lang="en-US"/>
               <a:t>Click to edit Master title style</a:t>
             </a:r>
-            <a:endParaRPr lang="en-US"/>
           </a:p>
         </p:txBody>
       </p:sp>
@@ -420,38 +433,37 @@
           <a:p>
             <a:pPr lvl="0"/>
             <a:r>
-              <a:rPr lang="en-US" smtClean="0"/>
+              <a:rPr lang="en-US"/>
               <a:t>Click to edit Master text styles</a:t>
             </a:r>
           </a:p>
           <a:p>
             <a:pPr lvl="1"/>
             <a:r>
-              <a:rPr lang="en-US" smtClean="0"/>
+              <a:rPr lang="en-US"/>
               <a:t>Second level</a:t>
             </a:r>
           </a:p>
           <a:p>
             <a:pPr lvl="2"/>
             <a:r>
-              <a:rPr lang="en-US" smtClean="0"/>
+              <a:rPr lang="en-US"/>
               <a:t>Third level</a:t>
             </a:r>
           </a:p>
           <a:p>
             <a:pPr lvl="3"/>
             <a:r>
-              <a:rPr lang="en-US" smtClean="0"/>
+              <a:rPr lang="en-US"/>
               <a:t>Fourth level</a:t>
             </a:r>
           </a:p>
           <a:p>
             <a:pPr lvl="4"/>
             <a:r>
-              <a:rPr lang="en-US" smtClean="0"/>
+              <a:rPr lang="en-US"/>
               <a:t>Fifth level</a:t>
             </a:r>
-            <a:endParaRPr lang="en-US"/>
           </a:p>
         </p:txBody>
       </p:sp>
@@ -472,7 +484,7 @@
           <a:p>
             <a:fld id="{5BCAD085-E8A6-8845-BD4E-CB4CCA059FC4}" type="datetimeFigureOut">
               <a:rPr lang="en-US" smtClean="0"/>
-              <a:t>1/27/13</a:t>
+              <a:t>4/10/2026</a:t>
             </a:fld>
             <a:endParaRPr lang="en-US"/>
           </a:p>
@@ -571,10 +583,9 @@
           <a:lstStyle/>
           <a:p>
             <a:r>
-              <a:rPr lang="en-US" smtClean="0"/>
+              <a:rPr lang="en-US"/>
               <a:t>Click to edit Master title style</a:t>
             </a:r>
-            <a:endParaRPr lang="en-US"/>
           </a:p>
         </p:txBody>
       </p:sp>
@@ -600,38 +611,37 @@
           <a:p>
             <a:pPr lvl="0"/>
             <a:r>
-              <a:rPr lang="en-US" smtClean="0"/>
+              <a:rPr lang="en-US"/>
               <a:t>Click to edit Master text styles</a:t>
             </a:r>
           </a:p>
           <a:p>
             <a:pPr lvl="1"/>
             <a:r>
-              <a:rPr lang="en-US" smtClean="0"/>
+              <a:rPr lang="en-US"/>
               <a:t>Second level</a:t>
             </a:r>
           </a:p>
           <a:p>
             <a:pPr lvl="2"/>
             <a:r>
-              <a:rPr lang="en-US" smtClean="0"/>
+              <a:rPr lang="en-US"/>
               <a:t>Third level</a:t>
             </a:r>
           </a:p>
           <a:p>
             <a:pPr lvl="3"/>
             <a:r>
-              <a:rPr lang="en-US" smtClean="0"/>
+              <a:rPr lang="en-US"/>
               <a:t>Fourth level</a:t>
             </a:r>
           </a:p>
           <a:p>
             <a:pPr lvl="4"/>
             <a:r>
-              <a:rPr lang="en-US" smtClean="0"/>
+              <a:rPr lang="en-US"/>
               <a:t>Fifth level</a:t>
             </a:r>
-            <a:endParaRPr lang="en-US"/>
           </a:p>
         </p:txBody>
       </p:sp>
@@ -652,7 +662,7 @@
           <a:p>
             <a:fld id="{5BCAD085-E8A6-8845-BD4E-CB4CCA059FC4}" type="datetimeFigureOut">
               <a:rPr lang="en-US" smtClean="0"/>
-              <a:t>1/27/13</a:t>
+              <a:t>4/10/2026</a:t>
             </a:fld>
             <a:endParaRPr lang="en-US"/>
           </a:p>
@@ -746,10 +756,9 @@
           <a:lstStyle/>
           <a:p>
             <a:r>
-              <a:rPr lang="en-US" smtClean="0"/>
+              <a:rPr lang="en-US"/>
               <a:t>Click to edit Master title style</a:t>
             </a:r>
-            <a:endParaRPr lang="en-US"/>
           </a:p>
         </p:txBody>
       </p:sp>
@@ -770,38 +779,37 @@
           <a:p>
             <a:pPr lvl="0"/>
             <a:r>
-              <a:rPr lang="en-US" smtClean="0"/>
+              <a:rPr lang="en-US"/>
               <a:t>Click to edit Master text styles</a:t>
             </a:r>
           </a:p>
           <a:p>
             <a:pPr lvl="1"/>
             <a:r>
-              <a:rPr lang="en-US" smtClean="0"/>
+              <a:rPr lang="en-US"/>
               <a:t>Second level</a:t>
             </a:r>
           </a:p>
           <a:p>
             <a:pPr lvl="2"/>
             <a:r>
-              <a:rPr lang="en-US" smtClean="0"/>
+              <a:rPr lang="en-US"/>
               <a:t>Third level</a:t>
             </a:r>
           </a:p>
           <a:p>
             <a:pPr lvl="3"/>
             <a:r>
-              <a:rPr lang="en-US" smtClean="0"/>
+              <a:rPr lang="en-US"/>
               <a:t>Fourth level</a:t>
             </a:r>
           </a:p>
           <a:p>
             <a:pPr lvl="4"/>
             <a:r>
-              <a:rPr lang="en-US" smtClean="0"/>
+              <a:rPr lang="en-US"/>
               <a:t>Fifth level</a:t>
             </a:r>
-            <a:endParaRPr lang="en-US"/>
           </a:p>
         </p:txBody>
       </p:sp>
@@ -822,7 +830,7 @@
           <a:p>
             <a:fld id="{5BCAD085-E8A6-8845-BD4E-CB4CCA059FC4}" type="datetimeFigureOut">
               <a:rPr lang="en-US" smtClean="0"/>
-              <a:t>1/27/13</a:t>
+              <a:t>4/10/2026</a:t>
             </a:fld>
             <a:endParaRPr lang="en-US"/>
           </a:p>
@@ -925,10 +933,9 @@
           </a:lstStyle>
           <a:p>
             <a:r>
-              <a:rPr lang="en-US" smtClean="0"/>
+              <a:rPr lang="en-US"/>
               <a:t>Click to edit Master title style</a:t>
             </a:r>
-            <a:endParaRPr lang="en-US"/>
           </a:p>
         </p:txBody>
       </p:sp>
@@ -1045,7 +1052,7 @@
           <a:p>
             <a:pPr lvl="0"/>
             <a:r>
-              <a:rPr lang="en-US" smtClean="0"/>
+              <a:rPr lang="en-US"/>
               <a:t>Click to edit Master text styles</a:t>
             </a:r>
           </a:p>
@@ -1068,7 +1075,7 @@
           <a:p>
             <a:fld id="{5BCAD085-E8A6-8845-BD4E-CB4CCA059FC4}" type="datetimeFigureOut">
               <a:rPr lang="en-US" smtClean="0"/>
-              <a:t>1/27/13</a:t>
+              <a:t>4/10/2026</a:t>
             </a:fld>
             <a:endParaRPr lang="en-US"/>
           </a:p>
@@ -1162,10 +1169,9 @@
           <a:lstStyle/>
           <a:p>
             <a:r>
-              <a:rPr lang="en-US" smtClean="0"/>
+              <a:rPr lang="en-US"/>
               <a:t>Click to edit Master title style</a:t>
             </a:r>
-            <a:endParaRPr lang="en-US"/>
           </a:p>
         </p:txBody>
       </p:sp>
@@ -1219,38 +1225,37 @@
           <a:p>
             <a:pPr lvl="0"/>
             <a:r>
-              <a:rPr lang="en-US" smtClean="0"/>
+              <a:rPr lang="en-US"/>
               <a:t>Click to edit Master text styles</a:t>
             </a:r>
           </a:p>
           <a:p>
             <a:pPr lvl="1"/>
             <a:r>
-              <a:rPr lang="en-US" smtClean="0"/>
+              <a:rPr lang="en-US"/>
               <a:t>Second level</a:t>
             </a:r>
           </a:p>
           <a:p>
             <a:pPr lvl="2"/>
             <a:r>
-              <a:rPr lang="en-US" smtClean="0"/>
+              <a:rPr lang="en-US"/>
               <a:t>Third level</a:t>
             </a:r>
           </a:p>
           <a:p>
             <a:pPr lvl="3"/>
             <a:r>
-              <a:rPr lang="en-US" smtClean="0"/>
+              <a:rPr lang="en-US"/>
               <a:t>Fourth level</a:t>
             </a:r>
           </a:p>
           <a:p>
             <a:pPr lvl="4"/>
             <a:r>
-              <a:rPr lang="en-US" smtClean="0"/>
+              <a:rPr lang="en-US"/>
               <a:t>Fifth level</a:t>
             </a:r>
-            <a:endParaRPr lang="en-US"/>
           </a:p>
         </p:txBody>
       </p:sp>
@@ -1304,38 +1309,37 @@
           <a:p>
             <a:pPr lvl="0"/>
             <a:r>
-              <a:rPr lang="en-US" smtClean="0"/>
+              <a:rPr lang="en-US"/>
               <a:t>Click to edit Master text styles</a:t>
             </a:r>
           </a:p>
           <a:p>
             <a:pPr lvl="1"/>
             <a:r>
-              <a:rPr lang="en-US" smtClean="0"/>
+              <a:rPr lang="en-US"/>
               <a:t>Second level</a:t>
             </a:r>
           </a:p>
           <a:p>
             <a:pPr lvl="2"/>
             <a:r>
-              <a:rPr lang="en-US" smtClean="0"/>
+              <a:rPr lang="en-US"/>
               <a:t>Third level</a:t>
             </a:r>
           </a:p>
           <a:p>
             <a:pPr lvl="3"/>
             <a:r>
-              <a:rPr lang="en-US" smtClean="0"/>
+              <a:rPr lang="en-US"/>
               <a:t>Fourth level</a:t>
             </a:r>
           </a:p>
           <a:p>
             <a:pPr lvl="4"/>
             <a:r>
-              <a:rPr lang="en-US" smtClean="0"/>
+              <a:rPr lang="en-US"/>
               <a:t>Fifth level</a:t>
             </a:r>
-            <a:endParaRPr lang="en-US"/>
           </a:p>
         </p:txBody>
       </p:sp>
@@ -1356,7 +1360,7 @@
           <a:p>
             <a:fld id="{5BCAD085-E8A6-8845-BD4E-CB4CCA059FC4}" type="datetimeFigureOut">
               <a:rPr lang="en-US" smtClean="0"/>
-              <a:t>1/27/13</a:t>
+              <a:t>4/10/2026</a:t>
             </a:fld>
             <a:endParaRPr lang="en-US"/>
           </a:p>
@@ -1454,10 +1458,9 @@
           </a:lstStyle>
           <a:p>
             <a:r>
-              <a:rPr lang="en-US" smtClean="0"/>
+              <a:rPr lang="en-US"/>
               <a:t>Click to edit Master title style</a:t>
             </a:r>
-            <a:endParaRPr lang="en-US"/>
           </a:p>
         </p:txBody>
       </p:sp>
@@ -1520,7 +1523,7 @@
           <a:p>
             <a:pPr lvl="0"/>
             <a:r>
-              <a:rPr lang="en-US" smtClean="0"/>
+              <a:rPr lang="en-US"/>
               <a:t>Click to edit Master text styles</a:t>
             </a:r>
           </a:p>
@@ -1576,38 +1579,37 @@
           <a:p>
             <a:pPr lvl="0"/>
             <a:r>
-              <a:rPr lang="en-US" smtClean="0"/>
+              <a:rPr lang="en-US"/>
               <a:t>Click to edit Master text styles</a:t>
             </a:r>
           </a:p>
           <a:p>
             <a:pPr lvl="1"/>
             <a:r>
-              <a:rPr lang="en-US" smtClean="0"/>
+              <a:rPr lang="en-US"/>
               <a:t>Second level</a:t>
             </a:r>
           </a:p>
           <a:p>
             <a:pPr lvl="2"/>
             <a:r>
-              <a:rPr lang="en-US" smtClean="0"/>
+              <a:rPr lang="en-US"/>
               <a:t>Third level</a:t>
             </a:r>
           </a:p>
           <a:p>
             <a:pPr lvl="3"/>
             <a:r>
-              <a:rPr lang="en-US" smtClean="0"/>
+              <a:rPr lang="en-US"/>
               <a:t>Fourth level</a:t>
             </a:r>
           </a:p>
           <a:p>
             <a:pPr lvl="4"/>
             <a:r>
-              <a:rPr lang="en-US" smtClean="0"/>
+              <a:rPr lang="en-US"/>
               <a:t>Fifth level</a:t>
             </a:r>
-            <a:endParaRPr lang="en-US"/>
           </a:p>
         </p:txBody>
       </p:sp>
@@ -1670,7 +1672,7 @@
           <a:p>
             <a:pPr lvl="0"/>
             <a:r>
-              <a:rPr lang="en-US" smtClean="0"/>
+              <a:rPr lang="en-US"/>
               <a:t>Click to edit Master text styles</a:t>
             </a:r>
           </a:p>
@@ -1726,38 +1728,37 @@
           <a:p>
             <a:pPr lvl="0"/>
             <a:r>
-              <a:rPr lang="en-US" smtClean="0"/>
+              <a:rPr lang="en-US"/>
               <a:t>Click to edit Master text styles</a:t>
             </a:r>
           </a:p>
           <a:p>
             <a:pPr lvl="1"/>
             <a:r>
-              <a:rPr lang="en-US" smtClean="0"/>
+              <a:rPr lang="en-US"/>
               <a:t>Second level</a:t>
             </a:r>
           </a:p>
           <a:p>
             <a:pPr lvl="2"/>
             <a:r>
-              <a:rPr lang="en-US" smtClean="0"/>
+              <a:rPr lang="en-US"/>
               <a:t>Third level</a:t>
             </a:r>
           </a:p>
           <a:p>
             <a:pPr lvl="3"/>
             <a:r>
-              <a:rPr lang="en-US" smtClean="0"/>
+              <a:rPr lang="en-US"/>
               <a:t>Fourth level</a:t>
             </a:r>
           </a:p>
           <a:p>
             <a:pPr lvl="4"/>
             <a:r>
-              <a:rPr lang="en-US" smtClean="0"/>
+              <a:rPr lang="en-US"/>
               <a:t>Fifth level</a:t>
             </a:r>
-            <a:endParaRPr lang="en-US"/>
           </a:p>
         </p:txBody>
       </p:sp>
@@ -1778,7 +1779,7 @@
           <a:p>
             <a:fld id="{5BCAD085-E8A6-8845-BD4E-CB4CCA059FC4}" type="datetimeFigureOut">
               <a:rPr lang="en-US" smtClean="0"/>
-              <a:t>1/27/13</a:t>
+              <a:t>4/10/2026</a:t>
             </a:fld>
             <a:endParaRPr lang="en-US"/>
           </a:p>
@@ -1872,10 +1873,9 @@
           <a:lstStyle/>
           <a:p>
             <a:r>
-              <a:rPr lang="en-US" smtClean="0"/>
+              <a:rPr lang="en-US"/>
               <a:t>Click to edit Master title style</a:t>
             </a:r>
-            <a:endParaRPr lang="en-US"/>
           </a:p>
         </p:txBody>
       </p:sp>
@@ -1896,7 +1896,7 @@
           <a:p>
             <a:fld id="{5BCAD085-E8A6-8845-BD4E-CB4CCA059FC4}" type="datetimeFigureOut">
               <a:rPr lang="en-US" smtClean="0"/>
-              <a:t>1/27/13</a:t>
+              <a:t>4/10/2026</a:t>
             </a:fld>
             <a:endParaRPr lang="en-US"/>
           </a:p>
@@ -1991,7 +1991,7 @@
           <a:p>
             <a:fld id="{5BCAD085-E8A6-8845-BD4E-CB4CCA059FC4}" type="datetimeFigureOut">
               <a:rPr lang="en-US" smtClean="0"/>
-              <a:t>1/27/13</a:t>
+              <a:t>4/10/2026</a:t>
             </a:fld>
             <a:endParaRPr lang="en-US"/>
           </a:p>
@@ -2094,10 +2094,9 @@
           </a:lstStyle>
           <a:p>
             <a:r>
-              <a:rPr lang="en-US" smtClean="0"/>
+              <a:rPr lang="en-US"/>
               <a:t>Click to edit Master title style</a:t>
             </a:r>
-            <a:endParaRPr lang="en-US"/>
           </a:p>
         </p:txBody>
       </p:sp>
@@ -2151,38 +2150,37 @@
           <a:p>
             <a:pPr lvl="0"/>
             <a:r>
-              <a:rPr lang="en-US" smtClean="0"/>
+              <a:rPr lang="en-US"/>
               <a:t>Click to edit Master text styles</a:t>
             </a:r>
           </a:p>
           <a:p>
             <a:pPr lvl="1"/>
             <a:r>
-              <a:rPr lang="en-US" smtClean="0"/>
+              <a:rPr lang="en-US"/>
               <a:t>Second level</a:t>
             </a:r>
           </a:p>
           <a:p>
             <a:pPr lvl="2"/>
             <a:r>
-              <a:rPr lang="en-US" smtClean="0"/>
+              <a:rPr lang="en-US"/>
               <a:t>Third level</a:t>
             </a:r>
           </a:p>
           <a:p>
             <a:pPr lvl="3"/>
             <a:r>
-              <a:rPr lang="en-US" smtClean="0"/>
+              <a:rPr lang="en-US"/>
               <a:t>Fourth level</a:t>
             </a:r>
           </a:p>
           <a:p>
             <a:pPr lvl="4"/>
             <a:r>
-              <a:rPr lang="en-US" smtClean="0"/>
+              <a:rPr lang="en-US"/>
               <a:t>Fifth level</a:t>
             </a:r>
-            <a:endParaRPr lang="en-US"/>
           </a:p>
         </p:txBody>
       </p:sp>
@@ -2245,7 +2243,7 @@
           <a:p>
             <a:pPr lvl="0"/>
             <a:r>
-              <a:rPr lang="en-US" smtClean="0"/>
+              <a:rPr lang="en-US"/>
               <a:t>Click to edit Master text styles</a:t>
             </a:r>
           </a:p>
@@ -2268,7 +2266,7 @@
           <a:p>
             <a:fld id="{5BCAD085-E8A6-8845-BD4E-CB4CCA059FC4}" type="datetimeFigureOut">
               <a:rPr lang="en-US" smtClean="0"/>
-              <a:t>1/27/13</a:t>
+              <a:t>4/10/2026</a:t>
             </a:fld>
             <a:endParaRPr lang="en-US"/>
           </a:p>
@@ -2371,10 +2369,9 @@
           </a:lstStyle>
           <a:p>
             <a:r>
-              <a:rPr lang="en-US" smtClean="0"/>
+              <a:rPr lang="en-US"/>
               <a:t>Click to edit Master title style</a:t>
             </a:r>
-            <a:endParaRPr lang="en-US"/>
           </a:p>
         </p:txBody>
       </p:sp>
@@ -2498,7 +2495,7 @@
           <a:p>
             <a:pPr lvl="0"/>
             <a:r>
-              <a:rPr lang="en-US" smtClean="0"/>
+              <a:rPr lang="en-US"/>
               <a:t>Click to edit Master text styles</a:t>
             </a:r>
           </a:p>
@@ -2521,7 +2518,7 @@
           <a:p>
             <a:fld id="{5BCAD085-E8A6-8845-BD4E-CB4CCA059FC4}" type="datetimeFigureOut">
               <a:rPr lang="en-US" smtClean="0"/>
-              <a:t>1/27/13</a:t>
+              <a:t>4/10/2026</a:t>
             </a:fld>
             <a:endParaRPr lang="en-US"/>
           </a:p>
@@ -2630,10 +2627,9 @@
           <a:lstStyle/>
           <a:p>
             <a:r>
-              <a:rPr lang="en-US" smtClean="0"/>
+              <a:rPr lang="en-US"/>
               <a:t>Click to edit Master title style</a:t>
             </a:r>
-            <a:endParaRPr lang="en-US"/>
           </a:p>
         </p:txBody>
       </p:sp>
@@ -2664,38 +2660,37 @@
           <a:p>
             <a:pPr lvl="0"/>
             <a:r>
-              <a:rPr lang="en-US" smtClean="0"/>
+              <a:rPr lang="en-US"/>
               <a:t>Click to edit Master text styles</a:t>
             </a:r>
           </a:p>
           <a:p>
             <a:pPr lvl="1"/>
             <a:r>
-              <a:rPr lang="en-US" smtClean="0"/>
+              <a:rPr lang="en-US"/>
               <a:t>Second level</a:t>
             </a:r>
           </a:p>
           <a:p>
             <a:pPr lvl="2"/>
             <a:r>
-              <a:rPr lang="en-US" smtClean="0"/>
+              <a:rPr lang="en-US"/>
               <a:t>Third level</a:t>
             </a:r>
           </a:p>
           <a:p>
             <a:pPr lvl="3"/>
             <a:r>
-              <a:rPr lang="en-US" smtClean="0"/>
+              <a:rPr lang="en-US"/>
               <a:t>Fourth level</a:t>
             </a:r>
           </a:p>
           <a:p>
             <a:pPr lvl="4"/>
             <a:r>
-              <a:rPr lang="en-US" smtClean="0"/>
+              <a:rPr lang="en-US"/>
               <a:t>Fifth level</a:t>
             </a:r>
-            <a:endParaRPr lang="en-US"/>
           </a:p>
         </p:txBody>
       </p:sp>
@@ -2734,7 +2729,7 @@
           <a:p>
             <a:fld id="{5BCAD085-E8A6-8845-BD4E-CB4CCA059FC4}" type="datetimeFigureOut">
               <a:rPr lang="en-US" smtClean="0"/>
-              <a:t>1/27/13</a:t>
+              <a:t>4/10/2026</a:t>
             </a:fld>
             <a:endParaRPr lang="en-US"/>
           </a:p>
@@ -3093,7 +3088,7 @@
 </file>
 
 <file path=ppt/slides/slide1.xml><?xml version="1.0" encoding="utf-8"?>
-<p:sld xmlns:a="http://schemas.openxmlformats.org/drawingml/2006/main" xmlns:p="http://schemas.openxmlformats.org/presentationml/2006/main" xmlns:r="http://schemas.openxmlformats.org/officeDocument/2006/relationships">
+<p:sld xmlns:a="http://schemas.openxmlformats.org/drawingml/2006/main" xmlns:r="http://schemas.openxmlformats.org/officeDocument/2006/relationships" xmlns:p="http://schemas.openxmlformats.org/presentationml/2006/main">
   <p:cSld>
     <p:spTree>
       <p:nvGrpSpPr>
@@ -3101,7 +3096,14 @@
         <p:cNvGrpSpPr/>
         <p:nvPr/>
       </p:nvGrpSpPr>
-      <p:grpSpPr/>
+      <p:grpSpPr>
+        <a:xfrm>
+          <a:off x="0" y="0"/>
+          <a:ext cx="0" cy="0"/>
+          <a:chOff x="0" y="0"/>
+          <a:chExt cx="0" cy="0"/>
+        </a:xfrm>
+      </p:grpSpPr>
       <p:sp>
         <p:nvSpPr>
           <p:cNvPr id="2" name="Title 1"/>
@@ -3143,25 +3145,21 @@
             </a:r>
           </a:p>
           <a:p>
-            <a:pPr/>
-            <a:r>
-              <a:t>Title: Church of Uganda Management Information System</a:t>
-            </a:r>
-          </a:p>
-          <a:p>
-            <a:pPr/>
-            <a:r>
-              <a:t>Course: CIS 7205 Advanced Database Systems</a:t>
-            </a:r>
-          </a:p>
-          <a:p>
-            <a:pPr/>
-            <a:r>
-              <a:t>Student Name: [Your Name]</a:t>
-            </a:r>
-          </a:p>
-          <a:p>
-            <a:pPr/>
+            <a:r>
+              <a:t>Church of Uganda Management Information System</a:t>
+            </a:r>
+          </a:p>
+          <a:p>
+            <a:r>
+              <a:t>CIS 7205 Advanced Database Systems</a:t>
+            </a:r>
+          </a:p>
+          <a:p>
+            <a:r>
+              <a:t>Author: [Your Name]</a:t>
+            </a:r>
+          </a:p>
+          <a:p>
             <a:r>
               <a:t>Date: April 12, 2026</a:t>
             </a:r>
@@ -3177,7 +3175,7 @@
 </file>
 
 <file path=ppt/slides/slide10.xml><?xml version="1.0" encoding="utf-8"?>
-<p:sld xmlns:a="http://schemas.openxmlformats.org/drawingml/2006/main" xmlns:p="http://schemas.openxmlformats.org/presentationml/2006/main" xmlns:r="http://schemas.openxmlformats.org/officeDocument/2006/relationships">
+<p:sld xmlns:a="http://schemas.openxmlformats.org/drawingml/2006/main" xmlns:r="http://schemas.openxmlformats.org/officeDocument/2006/relationships" xmlns:p="http://schemas.openxmlformats.org/presentationml/2006/main">
   <p:cSld>
     <p:spTree>
       <p:nvGrpSpPr>
@@ -3185,7 +3183,14 @@
         <p:cNvGrpSpPr/>
         <p:nvPr/>
       </p:nvGrpSpPr>
-      <p:grpSpPr/>
+      <p:grpSpPr>
+        <a:xfrm>
+          <a:off x="0" y="0"/>
+          <a:ext cx="0" cy="0"/>
+          <a:chOff x="0" y="0"/>
+          <a:chExt cx="0" cy="0"/>
+        </a:xfrm>
+      </p:grpSpPr>
       <p:sp>
         <p:nvSpPr>
           <p:cNvPr id="2" name="Title 1"/>
@@ -3202,7 +3207,7 @@
           <a:lstStyle/>
           <a:p>
             <a:r>
-              <a:t>Slide 10: Prototype Application</a:t>
+              <a:t>Slide 10: Sample Data and Queries</a:t>
             </a:r>
           </a:p>
         </p:txBody>
@@ -3223,19 +3228,27 @@
           <a:lstStyle/>
           <a:p>
             <a:r>
-              <a:t>Web interface for members, sacraments, and transactions</a:t>
-            </a:r>
-          </a:p>
-          <a:p>
-            <a:pPr/>
-            <a:r>
-              <a:t>CRUD operations and summary views</a:t>
-            </a:r>
-          </a:p>
-          <a:p>
-            <a:pPr/>
-            <a:r>
-              <a:t>Demonstration of end-to-end flow</a:t>
+              <a:t>Member list with parish and household associations.</a:t>
+            </a:r>
+          </a:p>
+          <a:p>
+            <a:r>
+              <a:t>Count members by parish.</a:t>
+            </a:r>
+          </a:p>
+          <a:p>
+            <a:r>
+              <a:t>Recent confirmation records.</a:t>
+            </a:r>
+          </a:p>
+          <a:p>
+            <a:r>
+              <a:t>Financial rollup by archdeaconry and parish.</a:t>
+            </a:r>
+          </a:p>
+          <a:p>
+            <a:r>
+              <a:t>Parish financial summary view.</a:t>
             </a:r>
           </a:p>
         </p:txBody>
@@ -3249,7 +3262,7 @@
 </file>
 
 <file path=ppt/slides/slide11.xml><?xml version="1.0" encoding="utf-8"?>
-<p:sld xmlns:a="http://schemas.openxmlformats.org/drawingml/2006/main" xmlns:p="http://schemas.openxmlformats.org/presentationml/2006/main" xmlns:r="http://schemas.openxmlformats.org/officeDocument/2006/relationships">
+<p:sld xmlns:a="http://schemas.openxmlformats.org/drawingml/2006/main" xmlns:r="http://schemas.openxmlformats.org/officeDocument/2006/relationships" xmlns:p="http://schemas.openxmlformats.org/presentationml/2006/main">
   <p:cSld>
     <p:spTree>
       <p:nvGrpSpPr>
@@ -3257,7 +3270,14 @@
         <p:cNvGrpSpPr/>
         <p:nvPr/>
       </p:nvGrpSpPr>
-      <p:grpSpPr/>
+      <p:grpSpPr>
+        <a:xfrm>
+          <a:off x="0" y="0"/>
+          <a:ext cx="0" cy="0"/>
+          <a:chOff x="0" y="0"/>
+          <a:chExt cx="0" cy="0"/>
+        </a:xfrm>
+      </p:grpSpPr>
       <p:sp>
         <p:nvSpPr>
           <p:cNvPr id="2" name="Title 1"/>
@@ -3274,7 +3294,7 @@
           <a:lstStyle/>
           <a:p>
             <a:r>
-              <a:t>Slide 11: Sacramental and Financial Records</a:t>
+              <a:t>Slide 11: Prototype Application</a:t>
             </a:r>
           </a:p>
         </p:txBody>
@@ -3295,19 +3315,22 @@
           <a:lstStyle/>
           <a:p>
             <a:r>
-              <a:t>Sacrament capture for members</a:t>
-            </a:r>
-          </a:p>
-          <a:p>
-            <a:pPr/>
-            <a:r>
-              <a:t>Transaction capture for units</a:t>
-            </a:r>
-          </a:p>
-          <a:p>
-            <a:pPr/>
-            <a:r>
-              <a:t>Reporting support for church accountability</a:t>
+              <a:t>Node.js/Express backend with REST API.</a:t>
+            </a:r>
+          </a:p>
+          <a:p>
+            <a:r>
+              <a:t>Browser UI for CRUD operations.</a:t>
+            </a:r>
+          </a:p>
+          <a:p>
+            <a:r>
+              <a:t>Manage members, sacraments, and transactions.</a:t>
+            </a:r>
+          </a:p>
+          <a:p>
+            <a:r>
+              <a:t>Live summaries for membership and net balance.</a:t>
             </a:r>
           </a:p>
         </p:txBody>
@@ -3321,7 +3344,7 @@
 </file>
 
 <file path=ppt/slides/slide12.xml><?xml version="1.0" encoding="utf-8"?>
-<p:sld xmlns:a="http://schemas.openxmlformats.org/drawingml/2006/main" xmlns:p="http://schemas.openxmlformats.org/presentationml/2006/main" xmlns:r="http://schemas.openxmlformats.org/officeDocument/2006/relationships">
+<p:sld xmlns:a="http://schemas.openxmlformats.org/drawingml/2006/main" xmlns:r="http://schemas.openxmlformats.org/officeDocument/2006/relationships" xmlns:p="http://schemas.openxmlformats.org/presentationml/2006/main">
   <p:cSld>
     <p:spTree>
       <p:nvGrpSpPr>
@@ -3329,7 +3352,14 @@
         <p:cNvGrpSpPr/>
         <p:nvPr/>
       </p:nvGrpSpPr>
-      <p:grpSpPr/>
+      <p:grpSpPr>
+        <a:xfrm>
+          <a:off x="0" y="0"/>
+          <a:ext cx="0" cy="0"/>
+          <a:chOff x="0" y="0"/>
+          <a:chExt cx="0" cy="0"/>
+        </a:xfrm>
+      </p:grpSpPr>
       <p:sp>
         <p:nvSpPr>
           <p:cNvPr id="2" name="Title 1"/>
@@ -3367,19 +3397,22 @@
           <a:lstStyle/>
           <a:p>
             <a:r>
-              <a:t>Role-based access concepts</a:t>
-            </a:r>
-          </a:p>
-          <a:p>
-            <a:pPr/>
-            <a:r>
-              <a:t>Referential integrity and validation</a:t>
-            </a:r>
-          </a:p>
-          <a:p>
-            <a:pPr/>
-            <a:r>
-              <a:t>Data constraints and protection measures</a:t>
+              <a:t>Role-based access model in logical design.</a:t>
+            </a:r>
+          </a:p>
+          <a:p>
+            <a:r>
+              <a:t>Data validation in API requests.</a:t>
+            </a:r>
+          </a:p>
+          <a:p>
+            <a:r>
+              <a:t>Foreign keys and check constraints in database schema.</a:t>
+            </a:r>
+          </a:p>
+          <a:p>
+            <a:r>
+              <a:t>Unique constraints for users and roles.</a:t>
             </a:r>
           </a:p>
         </p:txBody>
@@ -3393,7 +3426,7 @@
 </file>
 
 <file path=ppt/slides/slide13.xml><?xml version="1.0" encoding="utf-8"?>
-<p:sld xmlns:a="http://schemas.openxmlformats.org/drawingml/2006/main" xmlns:p="http://schemas.openxmlformats.org/presentationml/2006/main" xmlns:r="http://schemas.openxmlformats.org/officeDocument/2006/relationships">
+<p:sld xmlns:a="http://schemas.openxmlformats.org/drawingml/2006/main" xmlns:r="http://schemas.openxmlformats.org/officeDocument/2006/relationships" xmlns:p="http://schemas.openxmlformats.org/presentationml/2006/main">
   <p:cSld>
     <p:spTree>
       <p:nvGrpSpPr>
@@ -3401,7 +3434,14 @@
         <p:cNvGrpSpPr/>
         <p:nvPr/>
       </p:nvGrpSpPr>
-      <p:grpSpPr/>
+      <p:grpSpPr>
+        <a:xfrm>
+          <a:off x="0" y="0"/>
+          <a:ext cx="0" cy="0"/>
+          <a:chOff x="0" y="0"/>
+          <a:chExt cx="0" cy="0"/>
+        </a:xfrm>
+      </p:grpSpPr>
       <p:sp>
         <p:nvSpPr>
           <p:cNvPr id="2" name="Title 1"/>
@@ -3418,7 +3458,7 @@
           <a:lstStyle/>
           <a:p>
             <a:r>
-              <a:t>Slide 13: Visual Summary</a:t>
+              <a:t>Slide 13: Submission and Deliverables</a:t>
             </a:r>
           </a:p>
         </p:txBody>
@@ -3439,19 +3479,32 @@
           <a:lstStyle/>
           <a:p>
             <a:r>
-              <a:t>System architecture overview</a:t>
-            </a:r>
-          </a:p>
-          <a:p>
-            <a:pPr/>
-            <a:r>
-              <a:t>Data flow from user input to reports</a:t>
-            </a:r>
-          </a:p>
-          <a:p>
-            <a:pPr/>
-            <a:r>
-              <a:t>Benefits for church governance</a:t>
+              <a:t>`CoU-MIS_Project_Report.docx`</a:t>
+            </a:r>
+          </a:p>
+          <a:p>
+            <a:r>
+              <a:t>`CoU-MIS_Presentation.pptx`</a:t>
+            </a:r>
+          </a:p>
+          <a:p>
+            <a:r>
+              <a:t>`Coursework/sql/schema.sql`</a:t>
+            </a:r>
+          </a:p>
+          <a:p>
+            <a:r>
+              <a:t>`Coursework/sql/sample_queries.sql`</a:t>
+            </a:r>
+          </a:p>
+          <a:p>
+            <a:r>
+              <a:t>`Coursework/app/` prototype files</a:t>
+            </a:r>
+          </a:p>
+          <a:p>
+            <a:r>
+              <a:t>`Coursework/Submission_Summary.md`</a:t>
             </a:r>
           </a:p>
         </p:txBody>
@@ -3465,7 +3518,7 @@
 </file>
 
 <file path=ppt/slides/slide14.xml><?xml version="1.0" encoding="utf-8"?>
-<p:sld xmlns:a="http://schemas.openxmlformats.org/drawingml/2006/main" xmlns:p="http://schemas.openxmlformats.org/presentationml/2006/main" xmlns:r="http://schemas.openxmlformats.org/officeDocument/2006/relationships">
+<p:sld xmlns:a="http://schemas.openxmlformats.org/drawingml/2006/main" xmlns:r="http://schemas.openxmlformats.org/officeDocument/2006/relationships" xmlns:p="http://schemas.openxmlformats.org/presentationml/2006/main">
   <p:cSld>
     <p:spTree>
       <p:nvGrpSpPr>
@@ -3473,7 +3526,14 @@
         <p:cNvGrpSpPr/>
         <p:nvPr/>
       </p:nvGrpSpPr>
-      <p:grpSpPr/>
+      <p:grpSpPr>
+        <a:xfrm>
+          <a:off x="0" y="0"/>
+          <a:ext cx="0" cy="0"/>
+          <a:chOff x="0" y="0"/>
+          <a:chExt cx="0" cy="0"/>
+        </a:xfrm>
+      </p:grpSpPr>
       <p:sp>
         <p:nvSpPr>
           <p:cNvPr id="2" name="Title 1"/>
@@ -3511,13 +3571,12 @@
           <a:lstStyle/>
           <a:p>
             <a:r>
-              <a:t>Summary of project achievements</a:t>
-            </a:r>
-          </a:p>
-          <a:p>
-            <a:pPr/>
-            <a:r>
-              <a:t>Future enhancements: authentication, dashboards, mobile app, certificates</a:t>
+              <a:t>Improved data accuracy, accountability, and reporting for Church of Uganda.</a:t>
+            </a:r>
+          </a:p>
+          <a:p>
+            <a:r>
+              <a:t>Future enhancements: authentication, dashboards, mobile app, certificate printing.</a:t>
             </a:r>
           </a:p>
         </p:txBody>
@@ -3531,7 +3590,7 @@
 </file>
 
 <file path=ppt/slides/slide15.xml><?xml version="1.0" encoding="utf-8"?>
-<p:sld xmlns:a="http://schemas.openxmlformats.org/drawingml/2006/main" xmlns:p="http://schemas.openxmlformats.org/presentationml/2006/main" xmlns:r="http://schemas.openxmlformats.org/officeDocument/2006/relationships">
+<p:sld xmlns:a="http://schemas.openxmlformats.org/drawingml/2006/main" xmlns:r="http://schemas.openxmlformats.org/officeDocument/2006/relationships" xmlns:p="http://schemas.openxmlformats.org/presentationml/2006/main">
   <p:cSld>
     <p:spTree>
       <p:nvGrpSpPr>
@@ -3539,7 +3598,14 @@
         <p:cNvGrpSpPr/>
         <p:nvPr/>
       </p:nvGrpSpPr>
-      <p:grpSpPr/>
+      <p:grpSpPr>
+        <a:xfrm>
+          <a:off x="0" y="0"/>
+          <a:ext cx="0" cy="0"/>
+          <a:chOff x="0" y="0"/>
+          <a:chExt cx="0" cy="0"/>
+        </a:xfrm>
+      </p:grpSpPr>
       <p:sp>
         <p:nvSpPr>
           <p:cNvPr id="2" name="Title 1"/>
@@ -3569,8 +3635,8 @@
         </p:nvSpPr>
         <p:spPr>
           <a:xfrm>
-            <a:off x="914400" y="1645920"/>
-            <a:ext cx="2743200" cy="1097280"/>
+            <a:off x="914400" y="1645919"/>
+            <a:ext cx="1899745" cy="1215521"/>
           </a:xfrm>
           <a:prstGeom prst="roundRect">
             <a:avLst/>
@@ -3613,8 +3679,8 @@
         </p:nvSpPr>
         <p:spPr>
           <a:xfrm>
-            <a:off x="4114800" y="1645920"/>
-            <a:ext cx="2743200" cy="1097280"/>
+            <a:off x="3610304" y="1645919"/>
+            <a:ext cx="1805152" cy="1215520"/>
           </a:xfrm>
           <a:prstGeom prst="roundRect">
             <a:avLst/>
@@ -3657,8 +3723,8 @@
         </p:nvSpPr>
         <p:spPr>
           <a:xfrm>
-            <a:off x="7315200" y="1645920"/>
-            <a:ext cx="2743200" cy="1097280"/>
+            <a:off x="5762296" y="1705038"/>
+            <a:ext cx="1947042" cy="1156401"/>
           </a:xfrm>
           <a:prstGeom prst="roundRect">
             <a:avLst/>
@@ -3683,11 +3749,13 @@
           <a:lstStyle/>
           <a:p>
             <a:r>
+              <a:rPr dirty="0"/>
               <a:t>Reports and Dashboard</a:t>
             </a:r>
           </a:p>
           <a:p>
             <a:r>
+              <a:rPr dirty="0"/>
               <a:t>(Financial &amp; Sacramental)</a:t>
             </a:r>
           </a:p>
@@ -3702,7 +3770,7 @@
 </file>
 
 <file path=ppt/slides/slide2.xml><?xml version="1.0" encoding="utf-8"?>
-<p:sld xmlns:a="http://schemas.openxmlformats.org/drawingml/2006/main" xmlns:p="http://schemas.openxmlformats.org/presentationml/2006/main" xmlns:r="http://schemas.openxmlformats.org/officeDocument/2006/relationships">
+<p:sld xmlns:a="http://schemas.openxmlformats.org/drawingml/2006/main" xmlns:r="http://schemas.openxmlformats.org/officeDocument/2006/relationships" xmlns:p="http://schemas.openxmlformats.org/presentationml/2006/main">
   <p:cSld>
     <p:spTree>
       <p:nvGrpSpPr>
@@ -3710,7 +3778,14 @@
         <p:cNvGrpSpPr/>
         <p:nvPr/>
       </p:nvGrpSpPr>
-      <p:grpSpPr/>
+      <p:grpSpPr>
+        <a:xfrm>
+          <a:off x="0" y="0"/>
+          <a:ext cx="0" cy="0"/>
+          <a:chOff x="0" y="0"/>
+          <a:chExt cx="0" cy="0"/>
+        </a:xfrm>
+      </p:grpSpPr>
       <p:sp>
         <p:nvSpPr>
           <p:cNvPr id="2" name="Title 1"/>
@@ -3748,19 +3823,17 @@
           <a:lstStyle/>
           <a:p>
             <a:r>
-              <a:t>Manual and fragmented church record-keeping</a:t>
-            </a:r>
-          </a:p>
-          <a:p>
-            <a:pPr/>
-            <a:r>
-              <a:t>Challenges: errors, delays, weak governance</a:t>
-            </a:r>
-          </a:p>
-          <a:p>
-            <a:pPr/>
-            <a:r>
-              <a:t>Need for a modern database solution</a:t>
+              <a:t>Many Church of Uganda units still use paper records and spreadsheets.</a:t>
+            </a:r>
+          </a:p>
+          <a:p>
+            <a:r>
+              <a:t>This causes data errors, slow reporting, weak financial governance, and poor hierarchical visibility.</a:t>
+            </a:r>
+          </a:p>
+          <a:p>
+            <a:r>
+              <a:t>The solution needs to support membership, sacraments, financial accountability, and church structure.</a:t>
             </a:r>
           </a:p>
         </p:txBody>
@@ -3774,7 +3847,7 @@
 </file>
 
 <file path=ppt/slides/slide3.xml><?xml version="1.0" encoding="utf-8"?>
-<p:sld xmlns:a="http://schemas.openxmlformats.org/drawingml/2006/main" xmlns:p="http://schemas.openxmlformats.org/presentationml/2006/main" xmlns:r="http://schemas.openxmlformats.org/officeDocument/2006/relationships">
+<p:sld xmlns:a="http://schemas.openxmlformats.org/drawingml/2006/main" xmlns:r="http://schemas.openxmlformats.org/officeDocument/2006/relationships" xmlns:p="http://schemas.openxmlformats.org/presentationml/2006/main">
   <p:cSld>
     <p:spTree>
       <p:nvGrpSpPr>
@@ -3782,7 +3855,14 @@
         <p:cNvGrpSpPr/>
         <p:nvPr/>
       </p:nvGrpSpPr>
-      <p:grpSpPr/>
+      <p:grpSpPr>
+        <a:xfrm>
+          <a:off x="0" y="0"/>
+          <a:ext cx="0" cy="0"/>
+          <a:chOff x="0" y="0"/>
+          <a:chExt cx="0" cy="0"/>
+        </a:xfrm>
+      </p:grpSpPr>
       <p:sp>
         <p:nvSpPr>
           <p:cNvPr id="2" name="Title 1"/>
@@ -3799,7 +3879,7 @@
           <a:lstStyle/>
           <a:p>
             <a:r>
-              <a:t>Slide 3: Project Objectives</a:t>
+              <a:t>Slide 3: Scope and Objectives</a:t>
             </a:r>
           </a:p>
         </p:txBody>
@@ -3820,31 +3900,27 @@
           <a:lstStyle/>
           <a:p>
             <a:r>
-              <a:t>Document real-world requirements</a:t>
-            </a:r>
-          </a:p>
-          <a:p>
-            <a:pPr/>
-            <a:r>
-              <a:t>Build an ER-based relational model</a:t>
-            </a:r>
-          </a:p>
-          <a:p>
-            <a:pPr/>
-            <a:r>
-              <a:t>Normalize to 3NF</a:t>
-            </a:r>
-          </a:p>
-          <a:p>
-            <a:pPr/>
-            <a:r>
-              <a:t>Implement in PostgreSQL</a:t>
-            </a:r>
-          </a:p>
-          <a:p>
-            <a:pPr/>
-            <a:r>
-              <a:t>Create a functional prototype UI</a:t>
+              <a:t>Design a database-driven system for church operations.</a:t>
+            </a:r>
+          </a:p>
+          <a:p>
+            <a:r>
+              <a:t>Support diocesan, archdeaconry, parish, and sub-parish hierarchy.</a:t>
+            </a:r>
+          </a:p>
+          <a:p>
+            <a:r>
+              <a:t>Register members and households.</a:t>
+            </a:r>
+          </a:p>
+          <a:p>
+            <a:r>
+              <a:t>Record sacraments and financial transactions.</a:t>
+            </a:r>
+          </a:p>
+          <a:p>
+            <a:r>
+              <a:t>Build a prototype UI and demonstrate advanced queries.</a:t>
             </a:r>
           </a:p>
         </p:txBody>
@@ -3858,7 +3934,7 @@
 </file>
 
 <file path=ppt/slides/slide4.xml><?xml version="1.0" encoding="utf-8"?>
-<p:sld xmlns:a="http://schemas.openxmlformats.org/drawingml/2006/main" xmlns:p="http://schemas.openxmlformats.org/presentationml/2006/main" xmlns:r="http://schemas.openxmlformats.org/officeDocument/2006/relationships">
+<p:sld xmlns:a="http://schemas.openxmlformats.org/drawingml/2006/main" xmlns:r="http://schemas.openxmlformats.org/officeDocument/2006/relationships" xmlns:p="http://schemas.openxmlformats.org/presentationml/2006/main">
   <p:cSld>
     <p:spTree>
       <p:nvGrpSpPr>
@@ -3866,7 +3942,14 @@
         <p:cNvGrpSpPr/>
         <p:nvPr/>
       </p:nvGrpSpPr>
-      <p:grpSpPr/>
+      <p:grpSpPr>
+        <a:xfrm>
+          <a:off x="0" y="0"/>
+          <a:ext cx="0" cy="0"/>
+          <a:chOff x="0" y="0"/>
+          <a:chExt cx="0" cy="0"/>
+        </a:xfrm>
+      </p:grpSpPr>
       <p:sp>
         <p:nvSpPr>
           <p:cNvPr id="2" name="Title 1"/>
@@ -3883,7 +3966,7 @@
           <a:lstStyle/>
           <a:p>
             <a:r>
-              <a:t>Slide 4: Stakeholders and Users</a:t>
+              <a:t>Slide 4: Stakeholders</a:t>
             </a:r>
           </a:p>
         </p:txBody>
@@ -3904,19 +3987,27 @@
           <a:lstStyle/>
           <a:p>
             <a:r>
-              <a:t>Bishop, Diocesan Secretary, Archdeacon</a:t>
-            </a:r>
-          </a:p>
-          <a:p>
-            <a:pPr/>
-            <a:r>
-              <a:t>Parish Priest, Treasurer, Lay Reader</a:t>
-            </a:r>
-          </a:p>
-          <a:p>
-            <a:pPr/>
-            <a:r>
-              <a:t>System Administrator, Church members</a:t>
+              <a:t>Bishop and Diocesan Secretary: governance and accountability.</a:t>
+            </a:r>
+          </a:p>
+          <a:p>
+            <a:r>
+              <a:t>Archdeacon and Parish Priest: operational oversight.</a:t>
+            </a:r>
+          </a:p>
+          <a:p>
+            <a:r>
+              <a:t>Treasurer: financial management.</a:t>
+            </a:r>
+          </a:p>
+          <a:p>
+            <a:r>
+              <a:t>Lay Reader and System Administrator: support and system control.</a:t>
+            </a:r>
+          </a:p>
+          <a:p>
+            <a:r>
+              <a:t>Church members: accurate sacraments and membership records.</a:t>
             </a:r>
           </a:p>
         </p:txBody>
@@ -3930,7 +4021,7 @@
 </file>
 
 <file path=ppt/slides/slide5.xml><?xml version="1.0" encoding="utf-8"?>
-<p:sld xmlns:a="http://schemas.openxmlformats.org/drawingml/2006/main" xmlns:p="http://schemas.openxmlformats.org/presentationml/2006/main" xmlns:r="http://schemas.openxmlformats.org/officeDocument/2006/relationships">
+<p:sld xmlns:a="http://schemas.openxmlformats.org/drawingml/2006/main" xmlns:r="http://schemas.openxmlformats.org/officeDocument/2006/relationships" xmlns:p="http://schemas.openxmlformats.org/presentationml/2006/main">
   <p:cSld>
     <p:spTree>
       <p:nvGrpSpPr>
@@ -3938,7 +4029,14 @@
         <p:cNvGrpSpPr/>
         <p:nvPr/>
       </p:nvGrpSpPr>
-      <p:grpSpPr/>
+      <p:grpSpPr>
+        <a:xfrm>
+          <a:off x="0" y="0"/>
+          <a:ext cx="0" cy="0"/>
+          <a:chOff x="0" y="0"/>
+          <a:chExt cx="0" cy="0"/>
+        </a:xfrm>
+      </p:grpSpPr>
       <p:sp>
         <p:nvSpPr>
           <p:cNvPr id="2" name="Title 1"/>
@@ -3955,7 +4053,7 @@
           <a:lstStyle/>
           <a:p>
             <a:r>
-              <a:t>Slide 5: System Requirements</a:t>
+              <a:t>Slide 5: Functional Requirements</a:t>
             </a:r>
           </a:p>
         </p:txBody>
@@ -3976,13 +4074,27 @@
           <a:lstStyle/>
           <a:p>
             <a:r>
-              <a:t>Functional: hierarchy, membership, sacraments, finance, reporting</a:t>
-            </a:r>
-          </a:p>
-          <a:p>
-            <a:pPr/>
-            <a:r>
-              <a:t>Non-functional: security, scalability, performance, reliability</a:t>
+              <a:t>Manage church hierarchy and organizational units.</a:t>
+            </a:r>
+          </a:p>
+          <a:p>
+            <a:r>
+              <a:t>Register households and individual members.</a:t>
+            </a:r>
+          </a:p>
+          <a:p>
+            <a:r>
+              <a:t>Maintain sacramental records for baptism, confirmation, marriage.</a:t>
+            </a:r>
+          </a:p>
+          <a:p>
+            <a:r>
+              <a:t>Track income and expenses by unit.</a:t>
+            </a:r>
+          </a:p>
+          <a:p>
+            <a:r>
+              <a:t>Generate reports and dashboards.</a:t>
             </a:r>
           </a:p>
         </p:txBody>
@@ -3996,7 +4108,7 @@
 </file>
 
 <file path=ppt/slides/slide6.xml><?xml version="1.0" encoding="utf-8"?>
-<p:sld xmlns:a="http://schemas.openxmlformats.org/drawingml/2006/main" xmlns:p="http://schemas.openxmlformats.org/presentationml/2006/main" xmlns:r="http://schemas.openxmlformats.org/officeDocument/2006/relationships">
+<p:sld xmlns:a="http://schemas.openxmlformats.org/drawingml/2006/main" xmlns:r="http://schemas.openxmlformats.org/officeDocument/2006/relationships" xmlns:p="http://schemas.openxmlformats.org/presentationml/2006/main">
   <p:cSld>
     <p:spTree>
       <p:nvGrpSpPr>
@@ -4004,7 +4116,14 @@
         <p:cNvGrpSpPr/>
         <p:nvPr/>
       </p:nvGrpSpPr>
-      <p:grpSpPr/>
+      <p:grpSpPr>
+        <a:xfrm>
+          <a:off x="0" y="0"/>
+          <a:ext cx="0" cy="0"/>
+          <a:chOff x="0" y="0"/>
+          <a:chExt cx="0" cy="0"/>
+        </a:xfrm>
+      </p:grpSpPr>
       <p:sp>
         <p:nvSpPr>
           <p:cNvPr id="2" name="Title 1"/>
@@ -4021,7 +4140,7 @@
           <a:lstStyle/>
           <a:p>
             <a:r>
-              <a:t>Slide 6: Conceptual Design Visual</a:t>
+              <a:t>Slide 6: Non-Functional Requirements</a:t>
             </a:r>
           </a:p>
         </p:txBody>
@@ -4042,19 +4161,27 @@
           <a:lstStyle/>
           <a:p>
             <a:r>
-              <a:t>ER diagram summary</a:t>
-            </a:r>
-          </a:p>
-          <a:p>
-            <a:pPr/>
-            <a:r>
-              <a:t>Entities: Diocese, Archdeaconry, Parish, SubParish, Household, Member, Sacrament, Transaction, Role, User</a:t>
-            </a:r>
-          </a:p>
-          <a:p>
-            <a:pPr/>
-            <a:r>
-              <a:t>Relationships and hierarchy</a:t>
+              <a:t>Security: role-based access and validation.</a:t>
+            </a:r>
+          </a:p>
+          <a:p>
+            <a:r>
+              <a:t>Integrity: constraints, foreign keys, and referential integrity.</a:t>
+            </a:r>
+          </a:p>
+          <a:p>
+            <a:r>
+              <a:t>Performance: responsive queries and simple UI.</a:t>
+            </a:r>
+          </a:p>
+          <a:p>
+            <a:r>
+              <a:t>Scalability: support many parishes and members.</a:t>
+            </a:r>
+          </a:p>
+          <a:p>
+            <a:r>
+              <a:t>Reliability: consistent transaction handling.</a:t>
             </a:r>
           </a:p>
         </p:txBody>
@@ -4068,7 +4195,7 @@
 </file>
 
 <file path=ppt/slides/slide7.xml><?xml version="1.0" encoding="utf-8"?>
-<p:sld xmlns:a="http://schemas.openxmlformats.org/drawingml/2006/main" xmlns:p="http://schemas.openxmlformats.org/presentationml/2006/main" xmlns:r="http://schemas.openxmlformats.org/officeDocument/2006/relationships">
+<p:sld xmlns:a="http://schemas.openxmlformats.org/drawingml/2006/main" xmlns:r="http://schemas.openxmlformats.org/officeDocument/2006/relationships" xmlns:p="http://schemas.openxmlformats.org/presentationml/2006/main">
   <p:cSld>
     <p:spTree>
       <p:nvGrpSpPr>
@@ -4076,7 +4203,14 @@
         <p:cNvGrpSpPr/>
         <p:nvPr/>
       </p:nvGrpSpPr>
-      <p:grpSpPr/>
+      <p:grpSpPr>
+        <a:xfrm>
+          <a:off x="0" y="0"/>
+          <a:ext cx="0" cy="0"/>
+          <a:chOff x="0" y="0"/>
+          <a:chExt cx="0" cy="0"/>
+        </a:xfrm>
+      </p:grpSpPr>
       <p:sp>
         <p:nvSpPr>
           <p:cNvPr id="2" name="Title 1"/>
@@ -4093,7 +4227,7 @@
           <a:lstStyle/>
           <a:p>
             <a:r>
-              <a:t>Slide 7: Logical Design and Normalization</a:t>
+              <a:t>Slide 7: Real ER Diagram</a:t>
             </a:r>
           </a:p>
         </p:txBody>
@@ -4114,19 +4248,22 @@
           <a:lstStyle/>
           <a:p>
             <a:r>
-              <a:t>Relational schema conversion</a:t>
-            </a:r>
-          </a:p>
-          <a:p>
-            <a:pPr/>
-            <a:r>
-              <a:t>3NF justification</a:t>
-            </a:r>
-          </a:p>
-          <a:p>
-            <a:pPr/>
-            <a:r>
-              <a:t>Key tables and foreign key structure</a:t>
+              <a:t>Show the actual ER diagram for CoU-MIS.</a:t>
+            </a:r>
+          </a:p>
+          <a:p>
+            <a:r>
+              <a:t>Include all entities: Diocese, Archdeaconry, Parish, SubParish, Household, Member, Sacrament, Transaction, Role, User.</a:t>
+            </a:r>
+          </a:p>
+          <a:p>
+            <a:r>
+              <a:t>Include key cardinalities and relationships: Diocese → Archdeaconry → Parish → SubParish → Household → Member.</a:t>
+            </a:r>
+          </a:p>
+          <a:p>
+            <a:r>
+              <a:t>Show member-to-sacrament and unit-to-transaction associations.</a:t>
             </a:r>
           </a:p>
         </p:txBody>
@@ -4140,7 +4277,7 @@
 </file>
 
 <file path=ppt/slides/slide8.xml><?xml version="1.0" encoding="utf-8"?>
-<p:sld xmlns:a="http://schemas.openxmlformats.org/drawingml/2006/main" xmlns:p="http://schemas.openxmlformats.org/presentationml/2006/main" xmlns:r="http://schemas.openxmlformats.org/officeDocument/2006/relationships">
+<p:sld xmlns:a="http://schemas.openxmlformats.org/drawingml/2006/main" xmlns:r="http://schemas.openxmlformats.org/officeDocument/2006/relationships" xmlns:p="http://schemas.openxmlformats.org/presentationml/2006/main">
   <p:cSld>
     <p:spTree>
       <p:nvGrpSpPr>
@@ -4148,7 +4285,14 @@
         <p:cNvGrpSpPr/>
         <p:nvPr/>
       </p:nvGrpSpPr>
-      <p:grpSpPr/>
+      <p:grpSpPr>
+        <a:xfrm>
+          <a:off x="0" y="0"/>
+          <a:ext cx="0" cy="0"/>
+          <a:chOff x="0" y="0"/>
+          <a:chExt cx="0" cy="0"/>
+        </a:xfrm>
+      </p:grpSpPr>
       <p:sp>
         <p:nvSpPr>
           <p:cNvPr id="2" name="Title 1"/>
@@ -4165,7 +4309,7 @@
           <a:lstStyle/>
           <a:p>
             <a:r>
-              <a:t>Slide 8: Database Implementation</a:t>
+              <a:t>Slide 8: Logical Schema and Normalization</a:t>
             </a:r>
           </a:p>
         </p:txBody>
@@ -4186,19 +4330,22 @@
           <a:lstStyle/>
           <a:p>
             <a:r>
-              <a:t>PostgreSQL schema highlights</a:t>
-            </a:r>
-          </a:p>
-          <a:p>
-            <a:pPr/>
-            <a:r>
-              <a:t>Table definitions and constraints</a:t>
-            </a:r>
-          </a:p>
-          <a:p>
-            <a:pPr/>
-            <a:r>
-              <a:t>View for parish financial summary</a:t>
+              <a:t>Relational tables defined for each entity.</a:t>
+            </a:r>
+          </a:p>
+          <a:p>
+            <a:r>
+              <a:t>Foreign keys enforce hierarchy and relationships.</a:t>
+            </a:r>
+          </a:p>
+          <a:p>
+            <a:r>
+              <a:t>Normalized to 3NF to avoid redundancy and update anomalies.</a:t>
+            </a:r>
+          </a:p>
+          <a:p>
+            <a:r>
+              <a:t>Separate event tables for sacraments and transactions.</a:t>
             </a:r>
           </a:p>
         </p:txBody>
@@ -4212,7 +4359,7 @@
 </file>
 
 <file path=ppt/slides/slide9.xml><?xml version="1.0" encoding="utf-8"?>
-<p:sld xmlns:a="http://schemas.openxmlformats.org/drawingml/2006/main" xmlns:p="http://schemas.openxmlformats.org/presentationml/2006/main" xmlns:r="http://schemas.openxmlformats.org/officeDocument/2006/relationships">
+<p:sld xmlns:a="http://schemas.openxmlformats.org/drawingml/2006/main" xmlns:r="http://schemas.openxmlformats.org/officeDocument/2006/relationships" xmlns:p="http://schemas.openxmlformats.org/presentationml/2006/main">
   <p:cSld>
     <p:spTree>
       <p:nvGrpSpPr>
@@ -4220,7 +4367,14 @@
         <p:cNvGrpSpPr/>
         <p:nvPr/>
       </p:nvGrpSpPr>
-      <p:grpSpPr/>
+      <p:grpSpPr>
+        <a:xfrm>
+          <a:off x="0" y="0"/>
+          <a:ext cx="0" cy="0"/>
+          <a:chOff x="0" y="0"/>
+          <a:chExt cx="0" cy="0"/>
+        </a:xfrm>
+      </p:grpSpPr>
       <p:sp>
         <p:nvSpPr>
           <p:cNvPr id="2" name="Title 1"/>
@@ -4237,7 +4391,7 @@
           <a:lstStyle/>
           <a:p>
             <a:r>
-              <a:t>Slide 9: Advanced Queries and Reports</a:t>
+              <a:t>Slide 9: Database Implementation</a:t>
             </a:r>
           </a:p>
         </p:txBody>
@@ -4258,25 +4412,17 @@
           <a:lstStyle/>
           <a:p>
             <a:r>
-              <a:t>Member counts by parish</a:t>
-            </a:r>
-          </a:p>
-          <a:p>
-            <a:pPr/>
-            <a:r>
-              <a:t>Recent sacramental records</a:t>
-            </a:r>
-          </a:p>
-          <a:p>
-            <a:pPr/>
-            <a:r>
-              <a:t>Financial rollups and dashboards</a:t>
-            </a:r>
-          </a:p>
-          <a:p>
-            <a:pPr/>
-            <a:r>
-              <a:t>Example query types</a:t>
+              <a:t>PostgreSQL schema in `Coursework/sql/schema.sql`.</a:t>
+            </a:r>
+          </a:p>
+          <a:p>
+            <a:r>
+              <a:t>Includes tables, primary and foreign keys, constraints, and a financial summary view.</a:t>
+            </a:r>
+          </a:p>
+          <a:p>
+            <a:r>
+              <a:t>Seed data added for dioceses, parishes, households, members, sacraments, users, and transactions.</a:t>
             </a:r>
           </a:p>
         </p:txBody>

</xml_diff>